<commit_message>
Proofreading: Royal Institute spelling (กะพริบ, นอต), clearer simulated vs real labels
- Deck: slide 12 titled as a real screening result; simulated figures labelled on slides 5 and 9;
  "fail" zone now says plan improvement (confirm before purchase); Wi-Fi dashboard marked as a concept;
  compensation needs a calibrated unit; LER wording; formal Thai phrasing
- Poster and docs: กะพริบ / นอต spelling; dissemination doc scopes "make all" to simulated numbers

Co-Authored-By: Claude Opus 5.5 <noreply@anthropic.com>
Claude-Session: https://claude.ai/code/session_0117EqVLPBj3ceK6FwdrTein
</commit_message>
<xml_diff>
--- a/poster/LightCheck-KM_poster_80x100_editable.pptx
+++ b/poster/LightCheck-KM_poster_80x100_editable.pptx
@@ -5787,7 +5787,7 @@
                 <a:ea typeface="IBM Plex Sans Thai" pitchFamily="34" charset="-122"/>
                 <a:cs typeface="IBM Plex Sans Thai" pitchFamily="34" charset="-120"/>
               </a:rPr>
-              <a:t> Render จากไฟล์ STL · 108×63×26 มม. · หัวรับแสงเสมอผิวฝา ไม่มีขอบบังแสง · ช่องน็อต 1/4" ใต้กล่องสำหรับขาตั้งกล้องที่ระดับ 75 ซม.</a:t>
+              <a:t> Render จากไฟล์ STL · 108×63×26 มม. · หัวรับแสงเสมอผิวฝา ไม่มีขอบบังแสง · ช่องนอต 1/4" ใต้กล่องสำหรับขาตั้งกล้องที่ระดับ 75 ซม.</a:t>
             </a:r>
             <a:endParaRPr lang="en-US" sz="1700" dirty="0"/>
           </a:p>
@@ -6323,14 +6323,14 @@
       </p:sp>
       <p:sp>
         <p:nvSpPr>
-          <p:cNvPr id="140" name="ข้อความ: เฉลี่ย 5 รอบ ลดผล LED กระพริบ · จอ…"/>
+          <p:cNvPr id="140" name="ข้อความ: เฉลี่ย 5 รอบ ลดผล LED กะพริบ · จอแ…"/>
           <p:cNvSpPr txBox="1"/>
           <p:nvPr/>
         </p:nvSpPr>
         <p:spPr>
           <a:xfrm>
             <a:off x="11009559" y="24141989"/>
-            <a:ext cx="6919173" cy="419070"/>
+            <a:ext cx="6784208" cy="419070"/>
           </a:xfrm>
           <a:prstGeom prst="rect">
             <a:avLst/>
@@ -6368,7 +6368,7 @@
                 <a:ea typeface="IBM Plex Sans Thai" pitchFamily="34" charset="-122"/>
                 <a:cs typeface="IBM Plex Sans Thai" pitchFamily="34" charset="-120"/>
               </a:rPr>
-              <a:t> ลดผล LED กระพริบ · จอแสดง </a:t>
+              <a:t> ลดผล LED กะพริบ · จอแสดง </a:t>
             </a:r>
             <a:pPr algn="l" indent="0" marL="0">
               <a:buNone/>

</xml_diff>

<commit_message>
Poster and deck: real photos of the assembled meter and the lid printing
- Poster figure 5: photo of the assembled LightCheck KM (replaces the placeholder)
- Poster figure 4 and deck slide 8: new Ender-6 print photo matching the final colours
- Repository stats on the poster and deck updated (20 docs, 5 STL, 20 Python tools)
- evidence/2026-10_prototype/ with the original photos

Co-Authored-By: Claude Opus 5.5 <noreply@anthropic.com>
Claude-Session: https://claude.ai/code/session_0117EqVLPBj3ceK6FwdrTein
</commit_message>
<xml_diff>
--- a/poster/LightCheck-KM_poster_80x100_editable.pptx
+++ b/poster/LightCheck-KM_poster_80x100_editable.pptx
@@ -5874,7 +5874,7 @@
       </p:sp>
       <p:pic>
         <p:nvPicPr>
-          <p:cNvPr id="130" name="ภาพที่ 5 (คลิกขวา &gt; Change Picture เพื่อใส่รูปเครื่องจริง)" descr="ภาพที่ 5 (คลิกขวา &gt; Change Picture เพื่อใส่รูปเครื่องจริง)">    </p:cNvPr>
+          <p:cNvPr id="130" name="ภาพที่ 5 เครื่องที่ประกอบเสร็จ" descr="ภาพที่ 5 เครื่องที่ประกอบเสร็จ">    </p:cNvPr>
           <p:cNvPicPr>
             <a:picLocks noChangeAspect="1"/>
           </p:cNvPicPr>
@@ -10500,7 +10500,7 @@
       </p:sp>
       <p:sp>
         <p:nvSpPr>
-          <p:cNvPr id="232" name="ข้อความ: 2 #4"/>
+          <p:cNvPr id="232" name="ข้อความ: 5 #3"/>
           <p:cNvSpPr txBox="1"/>
           <p:nvPr/>
         </p:nvSpPr>
@@ -10531,7 +10531,7 @@
                 <a:ea typeface="Kanit SemiBold" pitchFamily="34" charset="-122"/>
                 <a:cs typeface="Kanit SemiBold" pitchFamily="34" charset="-120"/>
               </a:rPr>
-              <a:t>2</a:t>
+              <a:t>5</a:t>
             </a:r>
             <a:endParaRPr lang="en-US" sz="4000" dirty="0"/>
           </a:p>
@@ -10578,7 +10578,7 @@
       </p:sp>
       <p:sp>
         <p:nvSpPr>
-          <p:cNvPr id="234" name="ข้อความ: 19"/>
+          <p:cNvPr id="234" name="ข้อความ: 20 #2"/>
           <p:cNvSpPr txBox="1"/>
           <p:nvPr/>
         </p:nvSpPr>
@@ -10609,7 +10609,7 @@
                 <a:ea typeface="Kanit SemiBold" pitchFamily="34" charset="-122"/>
                 <a:cs typeface="Kanit SemiBold" pitchFamily="34" charset="-120"/>
               </a:rPr>
-              <a:t>19</a:t>
+              <a:t>20</a:t>
             </a:r>
             <a:endParaRPr lang="en-US" sz="4000" dirty="0"/>
           </a:p>

</xml_diff>